<commit_message>
Forschungsfrage: Wintersportorte, Höhengrenze tief < 1200 m
Co-Authored-By: Claude Opus 5.5 <noreply@anthropic.com>
</commit_message>
<xml_diff>
--- a/presentation/folie_05_forschungsfrage.pptx
+++ b/presentation/folie_05_forschungsfrage.pptx
@@ -107,7 +107,7 @@
   <p:extLst>
     <p:ext uri="{521415D9-36F7-43E2-AB2F-B90AF26B5E84}">
       <p14:sectionLst xmlns:p14="http://schemas.microsoft.com/office/powerpoint/2010/main">
-        <p14:section name="Konzept" id="{e665839d-e4d1-1a86-7e02-fe3d27e7cea4}">
+        <p14:section name="Konzept" id="{7399d93d-b72d-661a-fa75-22c91fdc5a03}">
           <p14:sldIdLst>
             <p14:sldId id="256"/>
           </p14:sldIdLst>
@@ -517,6 +517,7 @@
             <a:r>
               <a:rPr lang="en-US" dirty="0"/>
               <a:t>Hauptfrage: Wir wollen nicht nur vorhersagen, sondern vergleichen. Der Kern ist der Vergleich der Höhenklassen: Für wen ist Schnee wichtiger, für tiefe oder für hohe Gemeinden? Damit geht die Frage über eine reine Vorhersage hinaus.
+Auswahl: Von den 186 Gemeinden der BFS-Statistik untersuchen wir die 45 Wintersportorte, also Orte mit mindestens einem Drittel der Logiernächte von Dezember bis März. Die Grenze für tief liegt bei 1200 m statt 1000 m, weil nur 3 Wintersportorte unter 1000 m liegen und damit kein Vergleich möglich wäre. Mit 1200 m haben wir 13 tiefe, 19 mittlere und 13 hohe Orte. Die Einteilung mit 1000 m rechnen wir als Robustheitscheck mit.
 Teilfragen: (a) Gästemix In- und Ausland, (b) ob die Schneeabhängigkeit in den letzten Jahren zugenommen hat.
 Hypothesen H1 bis H5 kurz durchgehen. H2 ist die zentrale Hypothese zum Höhenvergleich. H5 prüft, ob der Schnee-Effekt auch bleibt, wenn wir Wechselkurs, Ferien und Feiertage berücksichtigen.
 Rechts (Feedback Dozent): Neben Schnee und Temperatur nehmen wir weitere Variablen ins Modell: Sonnenstunden, Höhenklasse, Hotelkapazität, Gästemix sowie EUR/CHF-Kurs, deutsche und Schweizer Schulferien und Schweizer Feiertage. Wechselkurs, Ferien und Feiertage sind für alle Gemeinden gleich. Sie erklären Schwankungen zwischen Monaten und Jahren, nicht Unterschiede zwischen Orten.
@@ -1029,7 +1030,7 @@
         <p:spPr>
           <a:xfrm>
             <a:off x="822960" y="1234440"/>
-            <a:ext cx="3657600" cy="274320"/>
+            <a:ext cx="10561320" cy="274320"/>
           </a:xfrm>
           <a:prstGeom prst="rect">
             <a:avLst/>
@@ -1051,6 +1052,17 @@
                 </a:solidFill>
               </a:rPr>
               <a:t>HAUPTFRAGE</a:t>
+            </a:r>
+            <a:pPr indent="0" marL="0">
+              <a:buNone/>
+            </a:pPr>
+            <a:r>
+              <a:rPr lang="en-US" sz="1100" dirty="0">
+                <a:solidFill>
+                  <a:schemeClr val="accent4"/>
+                </a:solidFill>
+              </a:rPr>
+              <a:t>     45 Wintersportorte  ·  tief &lt; 1200 m: 13  ·  mittel: 19  ·  hoch &gt; 1500 m: 13</a:t>
             </a:r>
             <a:endParaRPr lang="en-US" sz="1100" dirty="0"/>
           </a:p>
@@ -1086,7 +1098,7 @@
                   <a:schemeClr val="bg1"/>
                 </a:solidFill>
               </a:rPr>
-              <a:t>Wie stark beeinflussen Schneefall und Temperatur die Zimmerauslastung von Schweizer Hotels im Winter, und reagieren tief gelegene Tourismusgemeinden (unter 1000 m ü. M.) stärker als hoch gelegene (über 1500 m ü. M.)?</a:t>
+              <a:t>Wie stark beeinflussen Schneefall und Temperatur die Zimmerauslastung von Schweizer Hotels im Winter, und reagieren tief gelegene Wintersportorte (unter 1200 m ü. M.) stärker als hoch gelegene (über 1500 m ü. M.)?</a:t>
             </a:r>
             <a:endParaRPr lang="en-US" sz="1700" dirty="0"/>
           </a:p>

</xml_diff>